<commit_message>
Decide in advance which three slides lesson 9 drops
The segment that carries initialisation, optimisers and regularisation holds
about seventeen minutes of material in the thirteen its plan gives it. The
deck stays as it is - that was settled - so the remedy is in the room, and
this makes it a decision taken at the desk rather than at 17:40.

The three to drop are the initialisation block, chosen on evidence rather
than by taste: notebook 3 opens on the learning rate and never mentions
initialisation, the 0.6887 those slides quote was already measured in
notebook 01 two hours earlier, and handout sections 8.1 and 8.2 carry both
halves in full. They are about a fifth of the segment's spoken content,
which is the gap.

The note also says to announce the skip rather than making it silently, and
which one to keep if only one survives.

Co-Authored-By: Claude Opus 5 <noreply@anthropic.com>
Claude-Session: https://claude.ai/code/session_01AGVdtkDgZ58kt68DhqnwXC
</commit_message>
<xml_diff>
--- a/Lessons/09_neural_networks/Slides/neural_networks_slides.pptx
+++ b/Lessons/09_neural_networks/Slides/neural_networks_slides.pptx
@@ -5888,6 +5888,34 @@
               <a:t>Handout section 8.1.</a:t>
             </a:r>
           </a:p>
+          <a:p>
+            <a:pPr lvl="0" indent="0" marL="0">
+              <a:buNone/>
+            </a:pPr>
+          </a:p>
+          <a:p>
+            <a:pPr lvl="0" indent="0" marL="0">
+              <a:buNone/>
+            </a:pPr>
+            <a:r>
+              <a:rPr/>
+              <a:t>IF THE CLOCK IS AGAINST YOU, THESE ARE THE THREE TO DROP. This slide, the figure after it, and “How large? Propagate the variance” are the segment’s initialisation block, and it is the only block notebook 3 does not use - that notebook opens on the learning rate and never mentions initialisation. The 0.6887 they would have seen here was measured in notebook 01, two hours ago, so it is not new to them either. The handout carries both halves in full: section 8.1 derives the freeze exactly, 8.2 the variance argument.</a:t>
+            </a:r>
+          </a:p>
+          <a:p>
+            <a:pPr lvl="0" indent="0" marL="0">
+              <a:buNone/>
+            </a:pPr>
+          </a:p>
+          <a:p>
+            <a:pPr lvl="0" indent="0" marL="0">
+              <a:buNone/>
+            </a:pPr>
+            <a:r>
+              <a:rPr/>
+              <a:t>Dropping the three removes about a fifth of this segment’s spoken content, which is the difference between the material it holds and the time it has. Say out loud that you are skipping them and why - “the handout does this properly and the notebook does not need it” - because a silent skip reads as running out of time, and this one is a decision.</a:t>
+            </a:r>
+          </a:p>
         </p:txBody>
       </p:sp>
       <p:sp>
@@ -6006,6 +6034,20 @@
               <a:t>Handout section 8.1.</a:t>
             </a:r>
           </a:p>
+          <a:p>
+            <a:pPr lvl="0" indent="0" marL="0">
+              <a:buNone/>
+            </a:pPr>
+          </a:p>
+          <a:p>
+            <a:pPr lvl="0" indent="0" marL="0">
+              <a:buNone/>
+            </a:pPr>
+            <a:r>
+              <a:rPr/>
+              <a:t>Second of the three slides the note on “Zero cannot work” marks as droppable if the clock is against you.</a:t>
+            </a:r>
+          </a:p>
         </p:txBody>
       </p:sp>
       <p:sp>
@@ -6114,6 +6156,20 @@
             <a:r>
               <a:rPr/>
               <a:t>Handout section 8.2.</a:t>
+            </a:r>
+          </a:p>
+          <a:p>
+            <a:pPr lvl="0" indent="0" marL="0">
+              <a:buNone/>
+            </a:pPr>
+          </a:p>
+          <a:p>
+            <a:pPr lvl="0" indent="0" marL="0">
+              <a:buNone/>
+            </a:pPr>
+            <a:r>
+              <a:rPr/>
+              <a:t>Third of the three slides the note on “Zero cannot work” marks as droppable if the clock is against you. If you keep only one of the three, keep this one - He initialisation is the line they will actually type.</a:t>
             </a:r>
           </a:p>
         </p:txBody>

</xml_diff>

<commit_message>
Draw the sigmoid, and the perceptron's step, in lesson 9's neuron figure
The sigmoid was first drawn on slide 51, long after slides 6 to 8 had
used it. The neuron figure on slide 8 now carries a small plot under the
sigma node: the sigmoid's S-curve against the 1958 perceptron's step,
both switching at z = 0, one smoothly. Notes and the handout caption say
why the smooth one matters: a step has no slope to follow.

Co-Authored-By: Claude Opus 5.5 <noreply@anthropic.com>
</commit_message>
<xml_diff>
--- a/Lessons/09_neural_networks/Slides/neural_networks_slides.pptx
+++ b/Lessons/09_neural_networks/Slides/neural_networks_slides.pptx
@@ -8265,7 +8265,21 @@
             </a:pPr>
             <a:r>
               <a:rPr/>
-              <a:t>The previous slide’s formula as a picture, with numbers: w1 = 1, w2 = 2, b = -1. Point at the left half first. Two inputs arrive, each multiplied by its weight; a third input that is always 1 carries the bias, so the bias is just one more weight. The sum z goes through the sigmoid, and out comes y-hat between 0 and 1. Rosenblatt’s 1958 perceptron had a step where the sigmoid is: output 1 when z is positive, 0 otherwise.</a:t>
+              <a:t>The previous slide’s formula as a picture, with numbers: w1 = 1, w2 = 2, b = -1. Point at the left half first. Two inputs arrive, each multiplied by its weight; a third input that is always 1 carries the bias, so the bias is just one more weight. The sum z goes through the sigmoid, and out comes y-hat between 0 and 1.</a:t>
+            </a:r>
+          </a:p>
+          <a:p>
+            <a:pPr lvl="0" indent="0" marL="0">
+              <a:buNone/>
+            </a:pPr>
+          </a:p>
+          <a:p>
+            <a:pPr lvl="0" indent="0" marL="0">
+              <a:buNone/>
+            </a:pPr>
+            <a:r>
+              <a:rPr/>
+              <a:t>The small plot under the sigma node is the sigmoid itself, the gold S-curve: very negative z gives almost 0, very positive z almost 1, and z = 0 gives exactly 0.5. The dashed line is what Rosenblatt’s 1958 perceptron used in its place, a step: output 1 when z is positive, 0 otherwise. Both switch at the same place, z = 0; the sigmoid does it smoothly, which is what lets lesson 4’s gradient descent - and today’s backpropagation - work, since a step has no slope to follow.</a:t>
             </a:r>
           </a:p>
           <a:p>
@@ -21532,8 +21546,8 @@
         </p:blipFill>
         <p:spPr bwMode="auto">
           <a:xfrm>
-            <a:off x="563694" y="1166099"/>
-            <a:ext cx="8016611" cy="3360181"/>
+            <a:off x="645496" y="1166099"/>
+            <a:ext cx="7853007" cy="3360181"/>
           </a:xfrm>
           <a:prstGeom prst="rect">
             <a:avLst/>

</xml_diff>

<commit_message>
Say where lesson 9's 0.5422 comes from: the normal, before any model
Slide 12 printed P(|z| < 1.25) = 0.5422 without saying it is no model's
output, and the normality it rests on was stated nowhere on the slides.
Slide 11 now says the production offsets are normal, so standardised
units are points of a standard two-dimensional normal; slide 12 is
retitled "Before any model", and its notes read the formula and tie the
pass rate to the 0.55 of always answering "accepted". Handout section
2.2 says the same.

Co-Authored-By: Claude Opus 5.5 <noreply@anthropic.com>
</commit_message>
<xml_diff>
--- a/Lessons/09_neural_networks/Slides/neural_networks_slides.pptx
+++ b/Lessons/09_neural_networks/Slides/neural_networks_slides.pptx
@@ -717,6 +717,20 @@
             </a:pPr>
             <a:r>
               <a:rPr/>
+              <a:t>The fourth bullet is the assumption the next slide needs: the generator draws each offset from a normal distribution with that spread (instrument_data.py, TRUE_GAIN_SIGMA_DB and TRUE_PHASE_SIGMA_DEG). Divide each axis by its spread and every unit becomes a point of the standard two-dimensional normal, centred on the origin with spread 1 in every direction.</a:t>
+            </a:r>
+          </a:p>
+          <a:p>
+            <a:pPr lvl="0" indent="0" marL="0">
+              <a:buNone/>
+            </a:pPr>
+          </a:p>
+          <a:p>
+            <a:pPr lvl="0" indent="0" marL="0">
+              <a:buNone/>
+            </a:pPr>
+            <a:r>
+              <a:rPr/>
               <a:t>The measured 0.5497 is worth stating before the theoretical number on the next slide, so that the comparison runs from data to formula rather than the other way round.</a:t>
             </a:r>
           </a:p>
@@ -813,21 +827,21 @@
             </a:pPr>
             <a:r>
               <a:rPr/>
-              <a:t>The middle step is left off the slide so the formula stays large enough to read: 1.25 squared over two is 0.78125, and that is the exponent. Do it out loud.</a:t>
-            </a:r>
-          </a:p>
-          <a:p>
-            <a:pPr lvl="0" indent="0" marL="0">
-              <a:buNone/>
-            </a:pPr>
-          </a:p>
-          <a:p>
-            <a:pPr lvl="0" indent="0" marL="0">
-              <a:buNone/>
-            </a:pPr>
-            <a:r>
-              <a:rPr/>
-              <a:t>For a standard two-dimensional normal the probability of landing inside a circle of radius s is one minus e to the minus s squared over two - a fact worth a moment, since it is the same integral that reappears in section 11 when the lesson computes how well a polygon of a given number of sides could fence this region.</a:t>
+              <a:t>Say first what this number is NOT: it does not come from a model, and nothing has been fitted yet. It is a prediction from probability theory alone, from the previous slide’s assumption that the standardised offsets are a standard two-dimensional normal.</a:t>
+            </a:r>
+          </a:p>
+          <a:p>
+            <a:pPr lvl="0" indent="0" marL="0">
+              <a:buNone/>
+            </a:pPr>
+          </a:p>
+          <a:p>
+            <a:pPr lvl="0" indent="0" marL="0">
+              <a:buNone/>
+            </a:pPr>
+            <a:r>
+              <a:rPr/>
+              <a:t>Read the symbols: z is one unit’s pair of standardised offsets, the double bars are its distance from the origin, so the left side is “the probability that a unit lands inside the circle of radius 1.25” - the probability that it passes. For a standard two-dimensional normal the probability of landing inside a circle of radius s is one minus e to the minus s squared over two. The middle step is left off the slide so the formula stays large enough to read: 1.25 squared over two is 0.78125, and that is the exponent. Do it out loud.</a:t>
             </a:r>
           </a:p>
           <a:p>
@@ -842,6 +856,34 @@
             <a:r>
               <a:rPr/>
               <a:t>0.5422 predicted, 0.5497 measured on 3,000 units. The gap is sampling noise on three thousand draws and nothing else.</a:t>
+            </a:r>
+          </a:p>
+          <a:p>
+            <a:pPr lvl="0" indent="0" marL="0">
+              <a:buNone/>
+            </a:pPr>
+          </a:p>
+          <a:p>
+            <a:pPr lvl="0" indent="0" marL="0">
+              <a:buNone/>
+            </a:pPr>
+            <a:r>
+              <a:rPr/>
+              <a:t>Why it matters for what follows: a little over half of all units pass, so a model that answers “accepted” for every unit, using no measurement at all, is already right about 55% of the time. That is the first row of the next slide’s table, and the number every straight line will be compared against.</a:t>
+            </a:r>
+          </a:p>
+          <a:p>
+            <a:pPr lvl="0" indent="0" marL="0">
+              <a:buNone/>
+            </a:pPr>
+          </a:p>
+          <a:p>
+            <a:pPr lvl="0" indent="0" marL="0">
+              <a:buNone/>
+            </a:pPr>
+            <a:r>
+              <a:rPr/>
+              <a:t>The same integral reappears in section 11, when the lesson computes how well a polygon of a given number of sides could fence this region.</a:t>
             </a:r>
           </a:p>
           <a:p>
@@ -11842,7 +11884,7 @@
             <a:pPr lvl="0"/>
             <a:r>
               <a:rPr/>
-              <a:t>Gain tolerance </a:t>
+              <a:t>Tolerances </a:t>
             </a:r>
             <a:r>
               <a:rPr b="1"/>
@@ -11850,26 +11892,23 @@
             </a:r>
             <a:r>
               <a:rPr/>
-              <a:t>, production spread (standard deviation) </a:t>
+              <a:t> dB and </a:t>
+            </a:r>
+            <a:r>
+              <a:rPr b="1"/>
+              <a:t>3.75</a:t>
+            </a:r>
+            <a:r>
+              <a:rPr/>
+              <a:t>°; production spreads (standard deviations) </a:t>
             </a:r>
             <a:r>
               <a:rPr b="1"/>
               <a:t>0.40</a:t>
             </a:r>
-          </a:p>
-          <a:p>
-            <a:pPr lvl="0"/>
-            <a:r>
-              <a:rPr/>
-              <a:t>Phase tolerance </a:t>
-            </a:r>
-            <a:r>
-              <a:rPr b="1"/>
-              <a:t>3.75</a:t>
-            </a:r>
-            <a:r>
-              <a:rPr/>
-              <a:t>, production spread </a:t>
+            <a:r>
+              <a:rPr/>
+              <a:t> and </a:t>
             </a:r>
             <a:r>
               <a:rPr b="1"/>
@@ -11895,7 +11934,15 @@
             <a:pPr lvl="0"/>
             <a:r>
               <a:rPr/>
-              <a:t>Two units, two tolerances, one shared shape</a:t>
+              <a:t>Production offsets are </a:t>
+            </a:r>
+            <a:r>
+              <a:rPr b="1"/>
+              <a:t>normally distributed</a:t>
+            </a:r>
+            <a:r>
+              <a:rPr/>
+              <a:t>: standardised, each unit is a random point of a standard two-dimensional normal</a:t>
             </a:r>
           </a:p>
           <a:p>
@@ -11906,7 +11953,7 @@
             </a:r>
             <a:r>
               <a:rPr/>
-              <a:t> of the 3,000 generated units fall inside it</a:t>
+              <a:t> of the 3,000 generated units fall inside the circle</a:t>
             </a:r>
           </a:p>
         </p:txBody>
@@ -11958,7 +12005,7 @@
             </a:pPr>
             <a:r>
               <a:rPr/>
-              <a:t>What fraction of units the circle holds</a:t>
+              <a:t>Before any model: the share inside, from the normal</a:t>
             </a:r>
           </a:p>
         </p:txBody>

</xml_diff>

<commit_message>
Say where every number on lesson 9's slides comes from
A pass over the deck as a student with only the slides, every number
checked against the cell that printed it. Two tables claimed five seeds
where the code runs three (slides 47 and 59), slide 52 gave 3,547 and
3,553 for six layers without saying they are eight and five seeds, and
slide 62's best of 0.9667 is a different sweep from slide 59's 0.9685.
Elsewhere the slides now name the model, data or calculation behind a
number (13, 15, 16, 25, 33, 48, 58, 65), define delta, the weight
gradient, the elementwise product and the relative error (36, 39, 42),
derive 1.1 in slide 20's notes, rewrite two elliptical lines (53, 56),
and put the 512x2 network on 300 digits before the regulariser table
that uses it (66 and 67 swapped).

Co-Authored-By: Claude Opus 5.5 <noreply@anthropic.com>
</commit_message>
<xml_diff>
--- a/Lessons/09_neural_networks/Slides/neural_networks_slides.pptx
+++ b/Lessons/09_neural_networks/Slides/neural_networks_slides.pptx
@@ -1763,6 +1763,20 @@
             </a:pPr>
             <a:r>
               <a:rPr/>
+              <a:t>Where 1.1 comes from, if asked: the output is above 0.5 when 10 h1 + 10 h2 - 1 is positive, that is when h1 + h2 &gt; 0.1. At most one hidden unit fires at a time, and the one that fires outputs |a + b| - 1, so the condition is |a + b| - 1 &gt; 0.1, which is |a + b| &gt; 1.1.</a:t>
+            </a:r>
+          </a:p>
+          <a:p>
+            <a:pPr lvl="0" indent="0" marL="0">
+              <a:buNone/>
+            </a:pPr>
+          </a:p>
+          <a:p>
+            <a:pPr lvl="0" indent="0" marL="0">
+              <a:buNone/>
+            </a:pPr>
+            <a:r>
+              <a:rPr/>
               <a:t>The sentence to leave in the room: whatever training does, </a:t>
             </a:r>
             <a:r>
@@ -3403,7 +3417,7 @@
             </a:pPr>
             <a:r>
               <a:rPr/>
-              <a:t>The two numbers in the title are the sanity check to run before training anything. A network at random initialisation should cost about log 2, roughly 0.693, on a balanced binary problem: it knows essentially nothing, and the cost says so. 0.6721 is that, slightly better than pure ignorance because the classes are not exactly balanced.</a:t>
+              <a:t>The two numbers in the title are the sanity check to run before training anything. The untrained network is notebook 1’s: four hidden units with random He initial weights, scored on the 2,250 acceptance training units. The second number is the cost of a model that says 0.5 for every unit, which is minus log of a half, ln 2. A network at random initialisation should cost about log 2, roughly 0.693, on a balanced binary problem: it knows essentially nothing, and the cost says so. 0.6721 is that, slightly better than pure ignorance because the classes are not exactly balanced.</a:t>
             </a:r>
           </a:p>
           <a:p>
@@ -5091,7 +5105,7 @@
             </a:pPr>
             <a:r>
               <a:rPr/>
-              <a:t>Handwritten digits, eight by eight, ten classes, five seeds per row. The </a:t>
+              <a:t>Handwritten digits, eight by eight, ten classes, three seeds per row. The </a:t>
             </a:r>
             <a:r>
               <a:rPr>
@@ -6731,7 +6745,7 @@
             </a:pPr>
             <a:r>
               <a:rPr/>
-              <a:t>The same network and the same data at five learning rates, three orders of magnitude apart, five seeds each. The learning rate is the first thing to sweep and the last thing to guess.</a:t>
+              <a:t>The same network and the same data at five learning rates, three orders of magnitude apart, three seeds each. The learning rate is the first thing to sweep and the last thing to guess.</a:t>
             </a:r>
           </a:p>
           <a:p>
@@ -7643,67 +7657,51 @@
             </a:pPr>
             <a:r>
               <a:rPr/>
-              <a:t>Trained with early stopping on validation, best weights restored, scored on a test set that nothing was chosen against, five seeds each. Name the three methods first: early stopping keeps the weights from the best epoch and is the cheapest regulariser there is; L2 adds a penalty on the squared weights, identical in form to Ridge in lesson 3; dropout deletes each unit independently on every training batch and rescales the survivors, so no unit can rely on any other being present.</a:t>
-            </a:r>
-          </a:p>
-          <a:p>
-            <a:pPr lvl="0" indent="0" marL="0">
-              <a:buNone/>
-            </a:pPr>
-          </a:p>
-          <a:p>
-            <a:pPr lvl="0" indent="0" marL="0">
-              <a:buNone/>
-            </a:pPr>
-            <a:r>
-              <a:rPr/>
-              <a:t>Now read the table the way lesson 5 asks. All three land between 0.7 and 1.0 points above early stopping alone, against a seed-to-seed spread of 0.1 to 0.7 points - one to two standard deviations. </a:t>
-            </a:r>
-            <a:r>
-              <a:rPr b="1"/>
-              <a:t>Enough to say they helped, nowhere near enough to rank them.</a:t>
-            </a:r>
-            <a:r>
-              <a:rPr/>
-              <a:t> On a single run with one seed you could comfortably have measured the three in any order.</a:t>
-            </a:r>
-          </a:p>
-          <a:p>
-            <a:pPr lvl="0" indent="0" marL="0">
-              <a:buNone/>
-            </a:pPr>
-          </a:p>
-          <a:p>
-            <a:pPr lvl="0" indent="0" marL="0">
-              <a:buNone/>
-            </a:pPr>
-            <a:r>
-              <a:rPr/>
-              <a:t>The </a:t>
-            </a:r>
-            <a:r>
-              <a:rPr>
-                <a:latin typeface="Courier"/>
-              </a:rPr>
-              <a:t>epochs run</a:t>
-            </a:r>
-            <a:r>
-              <a:rPr/>
-              <a:t> column says something the accuracy column cannot: L2 kept validation loss improving for roughly four times as long before early stopping fired. A real qualitative difference, in a comparison whose headline numbers are not separable.</a:t>
-            </a:r>
-          </a:p>
-          <a:p>
-            <a:pPr lvl="0" indent="0" marL="0">
-              <a:buNone/>
-            </a:pPr>
-          </a:p>
-          <a:p>
-            <a:pPr lvl="0" indent="0" marL="0">
-              <a:buNone/>
-            </a:pPr>
-            <a:r>
-              <a:rPr/>
-              <a:t>Handout section 10.3.</a:t>
+              <a:t>301,066 parameters on 300 training examples - a thousand parameters per example. On the left, training accuracy reaches 1.000 and stays there: the network has enough freedom to store the answers outright, and it does. Validation accuracy sits near 0.95 and stays there too, which classical bias-variance reasoning from lesson 5 does not lead you to expect.</a:t>
+            </a:r>
+          </a:p>
+          <a:p>
+            <a:pPr lvl="0" indent="0" marL="0">
+              <a:buNone/>
+            </a:pPr>
+          </a:p>
+          <a:p>
+            <a:pPr lvl="0" indent="0" marL="0">
+              <a:buNone/>
+            </a:pPr>
+            <a:r>
+              <a:rPr/>
+              <a:t>The right panel is the one to dwell on. Validation </a:t>
+            </a:r>
+            <a:r>
+              <a:rPr i="1"/>
+              <a:t>loss</a:t>
+            </a:r>
+            <a:r>
+              <a:rPr/>
+              <a:t> bottoms out at epoch 13 - the dotted line - and then climbs for the rest of training, while validation </a:t>
+            </a:r>
+            <a:r>
+              <a:rPr i="1"/>
+              <a:t>accuracy</a:t>
+            </a:r>
+            <a:r>
+              <a:rPr/>
+              <a:t> holds flat and in fact peaks later, at epoch 17. The network is not getting more answers wrong - it is getting steadily more confident about the ones it already has wrong. Accuracy cannot see that; cross-entropy can. Ask the room which of the two they would early-stop on, and why.</a:t>
+            </a:r>
+          </a:p>
+          <a:p>
+            <a:pPr lvl="0" indent="0" marL="0">
+              <a:buNone/>
+            </a:pPr>
+          </a:p>
+          <a:p>
+            <a:pPr lvl="0" indent="0" marL="0">
+              <a:buNone/>
+            </a:pPr>
+            <a:r>
+              <a:rPr/>
+              <a:t>Handout section 10.1.</a:t>
             </a:r>
           </a:p>
         </p:txBody>
@@ -7785,51 +7783,67 @@
             </a:pPr>
             <a:r>
               <a:rPr/>
-              <a:t>301,066 parameters on 300 training examples - a thousand parameters per example. On the left, training accuracy reaches 1.000 and stays there: the network has enough freedom to store the answers outright, and it does. Validation accuracy sits near 0.95 and stays there too, which classical bias-variance reasoning from lesson 5 does not lead you to expect.</a:t>
-            </a:r>
-          </a:p>
-          <a:p>
-            <a:pPr lvl="0" indent="0" marL="0">
-              <a:buNone/>
-            </a:pPr>
-          </a:p>
-          <a:p>
-            <a:pPr lvl="0" indent="0" marL="0">
-              <a:buNone/>
-            </a:pPr>
-            <a:r>
-              <a:rPr/>
-              <a:t>The right panel is the one to dwell on. Validation </a:t>
-            </a:r>
-            <a:r>
-              <a:rPr i="1"/>
-              <a:t>loss</a:t>
-            </a:r>
-            <a:r>
-              <a:rPr/>
-              <a:t> bottoms out at epoch 13 - the dotted line - and then climbs for the rest of training, while validation </a:t>
-            </a:r>
-            <a:r>
-              <a:rPr i="1"/>
-              <a:t>accuracy</a:t>
-            </a:r>
-            <a:r>
-              <a:rPr/>
-              <a:t> holds flat and in fact peaks later, at epoch 17. The network is not getting more answers wrong - it is getting steadily more confident about the ones it already has wrong. Accuracy cannot see that; cross-entropy can. Ask the room which of the two they would early-stop on, and why.</a:t>
-            </a:r>
-          </a:p>
-          <a:p>
-            <a:pPr lvl="0" indent="0" marL="0">
-              <a:buNone/>
-            </a:pPr>
-          </a:p>
-          <a:p>
-            <a:pPr lvl="0" indent="0" marL="0">
-              <a:buNone/>
-            </a:pPr>
-            <a:r>
-              <a:rPr/>
-              <a:t>Handout section 10.1.</a:t>
+              <a:t>Trained with early stopping on validation, best weights restored, scored on a test set that nothing was chosen against, five seeds each. Name the three methods first: early stopping keeps the weights from the best epoch and is the cheapest regulariser there is; L2 adds a penalty on the squared weights, identical in form to Ridge in lesson 3; dropout deletes each unit independently on every training batch and rescales the survivors, so no unit can rely on any other being present.</a:t>
+            </a:r>
+          </a:p>
+          <a:p>
+            <a:pPr lvl="0" indent="0" marL="0">
+              <a:buNone/>
+            </a:pPr>
+          </a:p>
+          <a:p>
+            <a:pPr lvl="0" indent="0" marL="0">
+              <a:buNone/>
+            </a:pPr>
+            <a:r>
+              <a:rPr/>
+              <a:t>Now read the table the way lesson 5 asks. All three land between 0.7 and 1.0 points above early stopping alone, against a seed-to-seed spread of 0.1 to 0.7 points - one to two standard deviations. </a:t>
+            </a:r>
+            <a:r>
+              <a:rPr b="1"/>
+              <a:t>Enough to say they helped, nowhere near enough to rank them.</a:t>
+            </a:r>
+            <a:r>
+              <a:rPr/>
+              <a:t> On a single run with one seed you could comfortably have measured the three in any order.</a:t>
+            </a:r>
+          </a:p>
+          <a:p>
+            <a:pPr lvl="0" indent="0" marL="0">
+              <a:buNone/>
+            </a:pPr>
+          </a:p>
+          <a:p>
+            <a:pPr lvl="0" indent="0" marL="0">
+              <a:buNone/>
+            </a:pPr>
+            <a:r>
+              <a:rPr/>
+              <a:t>The </a:t>
+            </a:r>
+            <a:r>
+              <a:rPr>
+                <a:latin typeface="Courier"/>
+              </a:rPr>
+              <a:t>epochs run</a:t>
+            </a:r>
+            <a:r>
+              <a:rPr/>
+              <a:t> column says something the accuracy column cannot: L2 kept validation loss improving for roughly four times as long before early stopping fired. A real qualitative difference, in a comparison whose headline numbers are not separable.</a:t>
+            </a:r>
+          </a:p>
+          <a:p>
+            <a:pPr lvl="0" indent="0" marL="0">
+              <a:buNone/>
+            </a:pPr>
+          </a:p>
+          <a:p>
+            <a:pPr lvl="0" indent="0" marL="0">
+              <a:buNone/>
+            </a:pPr>
+            <a:r>
+              <a:rPr/>
+              <a:t>Handout section 10.3.</a:t>
             </a:r>
           </a:p>
         </p:txBody>
@@ -12137,7 +12151,7 @@
                       </a:pPr>
                       <a:r>
                         <a:rPr/>
-                        <a:t>test accuracy</a:t>
+                        <a:t>accuracy</a:t>
                       </a:r>
                     </a:p>
                   </a:txBody>
@@ -12155,7 +12169,7 @@
                       </a:pPr>
                       <a:r>
                         <a:rPr/>
-                        <a:t>always predict “accepted”</a:t>
+                        <a:t>always predict “accepted”, on the 750 test units</a:t>
                       </a:r>
                     </a:p>
                   </a:txBody>
@@ -12187,7 +12201,7 @@
                       </a:pPr>
                       <a:r>
                         <a:rPr/>
-                        <a:t>fitted logistic regression</a:t>
+                        <a:t>fitted logistic regression, on the 750 test units</a:t>
                       </a:r>
                     </a:p>
                   </a:txBody>
@@ -12219,7 +12233,7 @@
                       </a:pPr>
                       <a:r>
                         <a:rPr/>
-                        <a:t>the best straight line for this population</a:t>
+                        <a:t>the best possible straight line, computed from the true distribution</a:t>
                       </a:r>
                     </a:p>
                   </a:txBody>
@@ -12433,7 +12447,7 @@
             <a:pPr lvl="0"/>
             <a:r>
               <a:rPr/>
-              <a:t>Coefficients </a:t>
+              <a:t>Fitted logistic regression: coefficients </a:t>
             </a:r>
             <a:r>
               <a:rPr b="1"/>
@@ -12447,12 +12461,9 @@
               <a:rPr b="1"/>
               <a:t>0.1892</a:t>
             </a:r>
-          </a:p>
-          <a:p>
-            <a:pPr lvl="0"/>
-            <a:r>
-              <a:rPr/>
-              <a:t>Almost exactly the constant model: no line does much better than that</a:t>
+            <a:r>
+              <a:rPr/>
+              <a:t>, almost exactly the constant model</a:t>
             </a:r>
           </a:p>
           <a:p>
@@ -12553,7 +12564,7 @@
             <a:pPr lvl="0"/>
             <a:r>
               <a:rPr/>
-              <a:t>The search tries 72,762 boundaries and scores the winner </a:t>
+              <a:t>181 directions × 201 offsets × 2 sides = 72,762 lines, all scored on the test set; the winner, </a:t>
             </a:r>
             <a:r>
               <a:rPr b="1"/>
@@ -12586,14 +12597,7 @@
             <a:pPr lvl="0"/>
             <a:r>
               <a:rPr/>
-              <a:t>Nothing was fitted. No parameter estimated. Only a choice made</a:t>
-            </a:r>
-          </a:p>
-          <a:p>
-            <a:pPr lvl="0"/>
-            <a:r>
-              <a:rPr/>
-              <a:t>Lesson 5’s argument, inside a lesson-9 experiment</a:t>
+              <a:t>Nothing was fitted: only a choice made. Lesson 5’s argument again</a:t>
             </a:r>
           </a:p>
         </p:txBody>
@@ -13573,7 +13577,7 @@
                       </a:pPr>
                       <a:r>
                         <a:rPr/>
-                        <a:t>hidden units</a:t>
+                        <a:t>hidden units (drift data)</a:t>
                       </a:r>
                     </a:p>
                   </a:txBody>
@@ -13589,7 +13593,7 @@
                       </a:pPr>
                       <a:r>
                         <a:rPr/>
-                        <a:t>median of 20 random starts</a:t>
+                        <a:t>median accuracy, 20 random starts</a:t>
                       </a:r>
                     </a:p>
                   </a:txBody>
@@ -15058,7 +15062,7 @@
             </a:pPr>
             <a:r>
               <a:rPr/>
-              <a:t>An untrained network costs 0.6721; guessing costs 0.6931</a:t>
+              <a:t>Untrained, the cost is 0.6721; predicting 0.5 for all, ln 2 = 0.6931</a:t>
             </a:r>
           </a:p>
         </p:txBody>
@@ -15365,11 +15369,23 @@
             <a:pPr lvl="0"/>
             <a:r>
               <a:rPr/>
-              <a:t>Carry the cost’s derivative for each layer’s </a:t>
+              <a:t>Carry </a:t>
+            </a:r>
+            <a:r>
+              <a:rPr b="1"/>
+              <a:t>δ</a:t>
+            </a:r>
+            <a:r>
+              <a:rPr/>
+              <a:t>, the cost’s derivative with respect to each layer’s </a:t>
             </a:r>
             <a:r>
               <a:rPr b="1"/>
               <a:t>pre-activations</a:t>
+            </a:r>
+            <a:r>
+              <a:rPr/>
+              <a:t> Z</a:t>
             </a:r>
           </a:p>
           <a:p>
@@ -15683,28 +15699,21 @@
             <a:pPr lvl="0"/>
             <a:r>
               <a:rPr/>
-              <a:t>Weight gradient = incoming activations, transposed, times the signal above</a:t>
+              <a:t>Weight gradient = incoming activations, transposed, times δ: for layer 2, (A⁽¹⁾)ᵀ δ⁽²⁾</a:t>
             </a:r>
           </a:p>
           <a:p>
             <a:pPr lvl="0"/>
             <a:r>
               <a:rPr/>
-              <a:t>To step down: multiply by the weight matrix above, then by the activation’s derivative</a:t>
+              <a:t>To step down: multiply δ by the weight matrix above, then elementwise (⊙) by the activation’s derivative g′</a:t>
             </a:r>
           </a:p>
           <a:p>
             <a:pPr lvl="0"/>
             <a:r>
               <a:rPr/>
-              <a:t>For the ReLU that derivative is an indicator: 1 where the pre-activation was positive</a:t>
-            </a:r>
-          </a:p>
-          <a:p>
-            <a:pPr lvl="0"/>
-            <a:r>
-              <a:rPr/>
-              <a:t>A unit that contributed nothing forward passes nothing backward</a:t>
+              <a:t>For the ReLU, g′ is 1 where the pre-activation was positive, 0 elsewhere: a unit silent going forward passes nothing back</a:t>
             </a:r>
           </a:p>
         </p:txBody>
@@ -16099,7 +16108,7 @@
             </a:r>
             <a:r>
               <a:rPr/>
-              <a:t>: it trains badly and looks like a modelling problem</a:t>
+              <a:t>: it just trains badly</a:t>
             </a:r>
           </a:p>
           <a:p>
@@ -16113,21 +16122,14 @@
             <a:pPr lvl="0"/>
             <a:r>
               <a:rPr/>
-              <a:t>Notebook 01: worst disagreement 1.97 × 10⁻⁸, median 7.83 × 10⁻¹¹</a:t>
+              <a:t>Relative error = |⁠numerical − analytic|⁠ ÷ (|⁠numerical|⁠ + |⁠analytic|⁠); notebook 01: worst 1.97 × 10⁻⁸, median 7.83 × 10⁻¹¹</a:t>
             </a:r>
           </a:p>
           <a:p>
             <a:pPr lvl="0"/>
             <a:r>
               <a:rPr b="1"/>
-              <a:t>Relative error below 10⁻⁶: believe it. Above 10⁻⁴: there is a bug</a:t>
-            </a:r>
-          </a:p>
-          <a:p>
-            <a:pPr lvl="0"/>
-            <a:r>
-              <a:rPr/>
-              <a:t>Four lines of code, and not optional</a:t>
+              <a:t>Below 10⁻⁶: believe it. Above 10⁻⁴: there is a bug</a:t>
             </a:r>
           </a:p>
         </p:txBody>
@@ -16810,7 +16812,7 @@
                       </a:pPr>
                       <a:r>
                         <a:rPr/>
-                        <a:t>architecture</a:t>
+                        <a:t>architecture, on the digits</a:t>
                       </a:r>
                     </a:p>
                   </a:txBody>
@@ -16858,7 +16860,7 @@
                       </a:pPr>
                       <a:r>
                         <a:rPr/>
-                        <a:t>sd over 5 seeds</a:t>
+                        <a:t>sd over 3 seeds</a:t>
                       </a:r>
                     </a:p>
                   </a:txBody>
@@ -17231,6 +17233,10 @@
             <a:r>
               <a:rPr b="1"/>
               <a:t>39 points</a:t>
+            </a:r>
+            <a:r>
+              <a:rPr/>
+              <a:t>: 0.55 for the line, about 0.94 with a few hidden units</a:t>
             </a:r>
           </a:p>
           <a:p>
@@ -17750,7 +17756,7 @@
             <a:pPr lvl="0"/>
             <a:r>
               <a:rPr/>
-              <a:t>Gradient at the last weight matrix ÷ gradient at the first: median </a:t>
+              <a:t>Six sigmoid layers, eight seeds: gradient size at the layer nearest the output ÷ at the first layer, median </a:t>
             </a:r>
             <a:r>
               <a:rPr b="1"/>
@@ -17761,7 +17767,7 @@
             <a:pPr lvl="0"/>
             <a:r>
               <a:rPr/>
-              <a:t>Over the same eight seeds it ranges </a:t>
+              <a:t>Over those eight seeds it ranges </a:t>
             </a:r>
             <a:r>
               <a:rPr b="1"/>
@@ -17786,7 +17792,7 @@
             <a:pPr lvl="0"/>
             <a:r>
               <a:rPr/>
-              <a:t>By depth: 9.5, 170, 3,553, 46,250 at two, four, six and eight layers</a:t>
+              <a:t>By depth, five seeds each: 9.5, 170, 3,553, 46,250 at two, four, six and eight layers</a:t>
             </a:r>
           </a:p>
         </p:txBody>
@@ -17838,7 +17844,7 @@
             </a:pPr>
             <a:r>
               <a:rPr/>
-              <a:t>Eighty epochs: only one of them never learns</a:t>
+              <a:t>Eighty epochs, three activations: only the sigmoid never learns</a:t>
             </a:r>
           </a:p>
         </p:txBody>
@@ -17926,11 +17932,7 @@
             <a:pPr lvl="0"/>
             <a:r>
               <a:rPr/>
-              <a:t>What kills the sigmoid is not squashing: it is </a:t>
-            </a:r>
-            <a:r>
-              <a:rPr i="1"/>
-              <a:t>where its derivative is bounded</a:t>
+              <a:t>tanh squashes too, but its derivative reaches 1; the sigmoid’s never exceeds ¼, and that is what kills it</a:t>
             </a:r>
           </a:p>
         </p:txBody>
@@ -18511,21 +18513,18 @@
             </a:r>
             <a:r>
               <a:rPr/>
-              <a:t> a network: every gradient is exactly zero</a:t>
+              <a:t> a network: </a:t>
+            </a:r>
+            <a:r>
+              <a:rPr b="1"/>
+              <a:t>only the output bias moves</a:t>
             </a:r>
           </a:p>
           <a:p>
             <a:pPr lvl="0"/>
             <a:r>
-              <a:rPr b="1"/>
-              <a:t>Only the output bias ever moves</a:t>
-            </a:r>
-          </a:p>
-          <a:p>
-            <a:pPr lvl="0"/>
-            <a:r>
-              <a:rPr/>
-              <a:t>The bias converges to the base rate, and the cost to the cost of always predicting it, the label entropy: </a:t>
+              <a:rPr/>
+              <a:t>It converges to the base rate, the cost to the label entropy: </a:t>
             </a:r>
             <a:r>
               <a:rPr b="1"/>
@@ -18536,11 +18535,15 @@
             <a:pPr lvl="0"/>
             <a:r>
               <a:rPr/>
-              <a:t>Distinct hidden columns: </a:t>
+              <a:t>32 hidden units started at zero end as </a:t>
             </a:r>
             <a:r>
               <a:rPr b="1"/>
-              <a:t>1 of 32</a:t>
+              <a:t>1 distinct unit</a:t>
+            </a:r>
+            <a:r>
+              <a:rPr/>
+              <a:t>, copied 32 times</a:t>
             </a:r>
           </a:p>
         </p:txBody>
@@ -18702,14 +18705,7 @@
             <a:pPr lvl="0"/>
             <a:r>
               <a:rPr/>
-              <a:t>A unit sums n inputs, so variance is multiplied by n × Var(w) each layer</a:t>
-            </a:r>
-          </a:p>
-          <a:p>
-            <a:pPr lvl="0"/>
-            <a:r>
-              <a:rPr/>
-              <a:t>Set Var(w) = 1/n: </a:t>
+              <a:t>Each layer multiplies the variance by n × Var(w): Var(w) = 1/n is </a:t>
             </a:r>
             <a:r>
               <a:rPr b="1"/>
@@ -18717,7 +18713,7 @@
             </a:r>
             <a:r>
               <a:rPr/>
-              <a:t>. ReLU halves it, so it wants 2/n: </a:t>
+              <a:t>; for ReLU, 2/n is </a:t>
             </a:r>
             <a:r>
               <a:rPr b="1"/>
@@ -18727,30 +18723,38 @@
           <a:p>
             <a:pPr lvl="0"/>
             <a:r>
+              <a:rPr/>
+              <a:t>Eight tanh layers of 64, weights of standard deviation 0.01: the signal </a:t>
+            </a:r>
+            <a:r>
               <a:rPr b="1"/>
-              <a:t>Too small collapses</a:t>
-            </a:r>
-            <a:r>
-              <a:rPr/>
-              <a:t>: indistinguishable from zero by layer 4</a:t>
+              <a:t>collapses</a:t>
+            </a:r>
+            <a:r>
+              <a:rPr/>
+              <a:t> to zero by layer 4</a:t>
             </a:r>
           </a:p>
           <a:p>
             <a:pPr lvl="0"/>
             <a:r>
+              <a:rPr/>
+              <a:t>Standard deviation 1: 73% of the last layer </a:t>
+            </a:r>
+            <a:r>
               <a:rPr b="1"/>
-              <a:t>Too large saturates</a:t>
-            </a:r>
-            <a:r>
-              <a:rPr/>
-              <a:t> rather than exploding: 73% of the last layer’s tanh units past |a| &gt; 0.99</a:t>
+              <a:t>saturates</a:t>
+            </a:r>
+            <a:r>
+              <a:rPr/>
+              <a:t>, |a| &gt; 0.99</a:t>
             </a:r>
           </a:p>
           <a:p>
             <a:pPr lvl="0"/>
             <a:r>
               <a:rPr/>
-              <a:t>Glorot loses half its spread over eight layers</a:t>
+              <a:t>Glorot keeps half its spread over the eight layers</a:t>
             </a:r>
           </a:p>
         </p:txBody>
@@ -18802,7 +18806,7 @@
             </a:pPr>
             <a:r>
               <a:rPr/>
-              <a:t>The learning rate, swept</a:t>
+              <a:t>The learning rate, swept: two layers of 64, on the digits</a:t>
             </a:r>
           </a:p>
         </p:txBody>
@@ -18844,7 +18848,7 @@
                       </a:pPr>
                       <a:r>
                         <a:rPr/>
-                        <a:t>α</a:t>
+                        <a:t>α, plain SGD, 60 epochs</a:t>
                       </a:r>
                     </a:p>
                   </a:txBody>
@@ -18892,7 +18896,7 @@
                       </a:pPr>
                       <a:r>
                         <a:rPr/>
-                        <a:t>sd over 5 seeds</a:t>
+                        <a:t>sd over 3 seeds</a:t>
                       </a:r>
                     </a:p>
                   </a:txBody>
@@ -19630,7 +19634,7 @@
             <a:pPr lvl="0"/>
             <a:r>
               <a:rPr/>
-              <a:t>At α = 1.0, </a:t>
+              <a:t>One layer of 64, 40 epochs: at α = 1.0, </a:t>
             </a:r>
             <a:r>
               <a:rPr b="1"/>
@@ -19638,7 +19642,7 @@
             </a:r>
             <a:r>
               <a:rPr/>
-              <a:t>: accuracy 0.9583 against a best of 0.9667</a:t>
+              <a:t>, validation accuracy 0.9583 against 0.9667 at α = 0.5</a:t>
             </a:r>
           </a:p>
         </p:txBody>
@@ -19945,7 +19949,7 @@
                       </a:pPr>
                       <a:r>
                         <a:rPr/>
-                        <a:t>optimiser</a:t>
+                        <a:t>optimiser, acceptance data, 16 hidden units</a:t>
                       </a:r>
                     </a:p>
                   </a:txBody>
@@ -20009,7 +20013,7 @@
                       </a:pPr>
                       <a:r>
                         <a:rPr/>
-                        <a:t>vs the true rule</a:t>
+                        <a:t>against the noise-free labels</a:t>
                       </a:r>
                     </a:p>
                   </a:txBody>
@@ -20257,509 +20261,6 @@
 </file>
 
 <file path=ppt/slides/slide66.xml><?xml version="1.0" encoding="utf-8"?>
-<p:sld xmlns:a="http://schemas.openxmlformats.org/drawingml/2006/main" xmlns:r="http://schemas.openxmlformats.org/officeDocument/2006/relationships" xmlns:p="http://schemas.openxmlformats.org/presentationml/2006/main">
-  <p:cSld>
-    <p:spTree>
-      <p:nvGrpSpPr>
-        <p:cNvPr id="1" name=""/>
-        <p:cNvGrpSpPr/>
-        <p:nvPr/>
-      </p:nvGrpSpPr>
-      <p:grpSpPr>
-        <a:xfrm>
-          <a:off x="0" y="0"/>
-          <a:ext cx="0" cy="0"/>
-          <a:chOff x="0" y="0"/>
-          <a:chExt cx="0" cy="0"/>
-        </a:xfrm>
-      </p:grpSpPr>
-      <p:sp>
-        <p:nvSpPr>
-          <p:cNvPr id="2" name="Title 1"/>
-          <p:cNvSpPr>
-            <a:spLocks noGrp="1"/>
-          </p:cNvSpPr>
-          <p:nvPr>
-            <p:ph type="title"/>
-          </p:nvPr>
-        </p:nvSpPr>
-        <p:spPr>
-          <a:xfrm>
-            <a:off x="457200" y="205979"/>
-            <a:ext cx="8229600" cy="857250"/>
-          </a:xfrm>
-        </p:spPr>
-        <p:txBody>
-          <a:bodyPr/>
-          <a:lstStyle/>
-          <a:p>
-            <a:pPr lvl="0" indent="0" marL="0">
-              <a:buNone/>
-            </a:pPr>
-            <a:r>
-              <a:rPr/>
-              <a:t>Three regularisers, and what they bought</a:t>
-            </a:r>
-          </a:p>
-        </p:txBody>
-      </p:sp>
-      <p:graphicFrame>
-        <p:nvGraphicFramePr>
-          <p:cNvPr id="6" name="Content Placeholder 5"/>
-          <p:cNvGraphicFramePr>
-            <a:graphicFrameLocks noGrp="1"/>
-          </p:cNvGraphicFramePr>
-          <p:nvPr>
-            <p:ph idx="1"/>
-          </p:nvPr>
-        </p:nvGraphicFramePr>
-        <p:xfrm>
-          <a:off x="457200" y="1166099"/>
-          <a:ext cx="8229600" cy="3390900"/>
-        </p:xfrm>
-        <a:graphic>
-          <a:graphicData uri="http://schemas.openxmlformats.org/drawingml/2006/table">
-            <a:tbl>
-              <a:tblPr firstRow="1" bandRow="1">
-                <a:tableStyleId>{5C22544A-7EE6-4342-B048-85BDC9FD1C3A}</a:tableStyleId>
-              </a:tblPr>
-              <a:tblGrid>
-                <a:gridCol w="1645920"/>
-                <a:gridCol w="1645920"/>
-                <a:gridCol w="1645920"/>
-                <a:gridCol w="1645920"/>
-                <a:gridCol w="1645920"/>
-              </a:tblGrid>
-              <a:tr h="0">
-                <a:tc>
-                  <a:txBody>
-                    <a:bodyPr/>
-                    <a:lstStyle/>
-                    <a:p>
-                      <a:pPr lvl="0" indent="0" marL="0">
-                        <a:buNone/>
-                      </a:pPr>
-                      <a:r>
-                        <a:rPr/>
-                        <a:t>method</a:t>
-                      </a:r>
-                    </a:p>
-                  </a:txBody>
-                  <a:tcPr/>
-                </a:tc>
-                <a:tc>
-                  <a:txBody>
-                    <a:bodyPr/>
-                    <a:lstStyle/>
-                    <a:p>
-                      <a:pPr lvl="0" indent="0" marL="0">
-                        <a:buNone/>
-                      </a:pPr>
-                      <a:r>
-                        <a:rPr/>
-                        <a:t>test accuracy</a:t>
-                      </a:r>
-                    </a:p>
-                  </a:txBody>
-                  <a:tcPr/>
-                </a:tc>
-                <a:tc>
-                  <a:txBody>
-                    <a:bodyPr/>
-                    <a:lstStyle/>
-                    <a:p>
-                      <a:pPr lvl="0" indent="0" marL="0">
-                        <a:buNone/>
-                      </a:pPr>
-                      <a:r>
-                        <a:rPr/>
-                        <a:t>sd over 5 seeds</a:t>
-                      </a:r>
-                    </a:p>
-                  </a:txBody>
-                  <a:tcPr/>
-                </a:tc>
-                <a:tc>
-                  <a:txBody>
-                    <a:bodyPr/>
-                    <a:lstStyle/>
-                    <a:p>
-                      <a:pPr lvl="0" indent="0" marL="0">
-                        <a:buNone/>
-                      </a:pPr>
-                      <a:r>
-                        <a:rPr/>
-                        <a:t>train − test gap</a:t>
-                      </a:r>
-                    </a:p>
-                  </a:txBody>
-                  <a:tcPr/>
-                </a:tc>
-                <a:tc>
-                  <a:txBody>
-                    <a:bodyPr/>
-                    <a:lstStyle/>
-                    <a:p>
-                      <a:pPr lvl="0" indent="0" marL="0">
-                        <a:buNone/>
-                      </a:pPr>
-                      <a:r>
-                        <a:rPr/>
-                        <a:t>epochs run</a:t>
-                      </a:r>
-                    </a:p>
-                  </a:txBody>
-                  <a:tcPr/>
-                </a:tc>
-              </a:tr>
-              <a:tr h="0">
-                <a:tc>
-                  <a:txBody>
-                    <a:bodyPr/>
-                    <a:lstStyle/>
-                    <a:p>
-                      <a:pPr lvl="0" indent="0" marL="0">
-                        <a:buNone/>
-                      </a:pPr>
-                      <a:r>
-                        <a:rPr/>
-                        <a:t>early stopping only (</a:t>
-                      </a:r>
-                      <a:r>
-                        <a:rPr>
-                          <a:latin typeface="Courier"/>
-                        </a:rPr>
-                        <a:t>EarlyStopping</a:t>
-                      </a:r>
-                      <a:r>
-                        <a:rPr/>
-                        <a:t>: keep the best epoch)</a:t>
-                      </a:r>
-                    </a:p>
-                  </a:txBody>
-                </a:tc>
-                <a:tc>
-                  <a:txBody>
-                    <a:bodyPr/>
-                    <a:lstStyle/>
-                    <a:p>
-                      <a:pPr lvl="0" indent="0" marL="0">
-                        <a:buNone/>
-                      </a:pPr>
-                      <a:r>
-                        <a:rPr/>
-                        <a:t>0.9411</a:t>
-                      </a:r>
-                    </a:p>
-                  </a:txBody>
-                </a:tc>
-                <a:tc>
-                  <a:txBody>
-                    <a:bodyPr/>
-                    <a:lstStyle/>
-                    <a:p>
-                      <a:pPr lvl="0" indent="0" marL="0">
-                        <a:buNone/>
-                      </a:pPr>
-                      <a:r>
-                        <a:rPr/>
-                        <a:t>0.0069</a:t>
-                      </a:r>
-                    </a:p>
-                  </a:txBody>
-                </a:tc>
-                <a:tc>
-                  <a:txBody>
-                    <a:bodyPr/>
-                    <a:lstStyle/>
-                    <a:p>
-                      <a:pPr lvl="0" indent="0" marL="0">
-                        <a:buNone/>
-                      </a:pPr>
-                      <a:r>
-                        <a:rPr/>
-                        <a:t>0.0589</a:t>
-                      </a:r>
-                    </a:p>
-                  </a:txBody>
-                </a:tc>
-                <a:tc>
-                  <a:txBody>
-                    <a:bodyPr/>
-                    <a:lstStyle/>
-                    <a:p>
-                      <a:pPr lvl="0" indent="0" marL="0">
-                        <a:buNone/>
-                      </a:pPr>
-                      <a:r>
-                        <a:rPr/>
-                        <a:t>38.8</a:t>
-                      </a:r>
-                    </a:p>
-                  </a:txBody>
-                </a:tc>
-              </a:tr>
-              <a:tr h="0">
-                <a:tc>
-                  <a:txBody>
-                    <a:bodyPr/>
-                    <a:lstStyle/>
-                    <a:p>
-                      <a:pPr lvl="0" indent="0" marL="0">
-                        <a:buNone/>
-                      </a:pPr>
-                      <a:r>
-                        <a:rPr/>
-                        <a:t>+ dropout 0.4 (</a:t>
-                      </a:r>
-                      <a:r>
-                        <a:rPr>
-                          <a:latin typeface="Courier"/>
-                        </a:rPr>
-                        <a:t>Dropout</a:t>
-                      </a:r>
-                      <a:r>
-                        <a:rPr/>
-                        <a:t>: drop 40% of units per batch)</a:t>
-                      </a:r>
-                    </a:p>
-                  </a:txBody>
-                </a:tc>
-                <a:tc>
-                  <a:txBody>
-                    <a:bodyPr/>
-                    <a:lstStyle/>
-                    <a:p>
-                      <a:pPr lvl="0" indent="0" marL="0">
-                        <a:buNone/>
-                      </a:pPr>
-                      <a:r>
-                        <a:rPr/>
-                        <a:t>0.9483</a:t>
-                      </a:r>
-                    </a:p>
-                  </a:txBody>
-                </a:tc>
-                <a:tc>
-                  <a:txBody>
-                    <a:bodyPr/>
-                    <a:lstStyle/>
-                    <a:p>
-                      <a:pPr lvl="0" indent="0" marL="0">
-                        <a:buNone/>
-                      </a:pPr>
-                      <a:r>
-                        <a:rPr/>
-                        <a:t>0.0038</a:t>
-                      </a:r>
-                    </a:p>
-                  </a:txBody>
-                </a:tc>
-                <a:tc>
-                  <a:txBody>
-                    <a:bodyPr/>
-                    <a:lstStyle/>
-                    <a:p>
-                      <a:pPr lvl="0" indent="0" marL="0">
-                        <a:buNone/>
-                      </a:pPr>
-                      <a:r>
-                        <a:rPr/>
-                        <a:t>0.0503</a:t>
-                      </a:r>
-                    </a:p>
-                  </a:txBody>
-                </a:tc>
-                <a:tc>
-                  <a:txBody>
-                    <a:bodyPr/>
-                    <a:lstStyle/>
-                    <a:p>
-                      <a:pPr lvl="0" indent="0" marL="0">
-                        <a:buNone/>
-                      </a:pPr>
-                      <a:r>
-                        <a:rPr/>
-                        <a:t>48.8</a:t>
-                      </a:r>
-                    </a:p>
-                  </a:txBody>
-                </a:tc>
-              </a:tr>
-              <a:tr h="0">
-                <a:tc>
-                  <a:txBody>
-                    <a:bodyPr/>
-                    <a:lstStyle/>
-                    <a:p>
-                      <a:pPr lvl="0" indent="0" marL="0">
-                        <a:buNone/>
-                      </a:pPr>
-                      <a:r>
-                        <a:rPr/>
-                        <a:t>+ L2 10⁻³ (</a:t>
-                      </a:r>
-                      <a:r>
-                        <a:rPr>
-                          <a:latin typeface="Courier"/>
-                        </a:rPr>
-                        <a:t>l2</a:t>
-                      </a:r>
-                      <a:r>
-                        <a:rPr/>
-                        <a:t>: a penalty on squared weights, as Ridge)</a:t>
-                      </a:r>
-                    </a:p>
-                  </a:txBody>
-                </a:tc>
-                <a:tc>
-                  <a:txBody>
-                    <a:bodyPr/>
-                    <a:lstStyle/>
-                    <a:p>
-                      <a:pPr lvl="0" indent="0" marL="0">
-                        <a:buNone/>
-                      </a:pPr>
-                      <a:r>
-                        <a:rPr/>
-                        <a:t>0.9478</a:t>
-                      </a:r>
-                    </a:p>
-                  </a:txBody>
-                </a:tc>
-                <a:tc>
-                  <a:txBody>
-                    <a:bodyPr/>
-                    <a:lstStyle/>
-                    <a:p>
-                      <a:pPr lvl="0" indent="0" marL="0">
-                        <a:buNone/>
-                      </a:pPr>
-                      <a:r>
-                        <a:rPr/>
-                        <a:t>0.0011</a:t>
-                      </a:r>
-                    </a:p>
-                  </a:txBody>
-                </a:tc>
-                <a:tc>
-                  <a:txBody>
-                    <a:bodyPr/>
-                    <a:lstStyle/>
-                    <a:p>
-                      <a:pPr lvl="0" indent="0" marL="0">
-                        <a:buNone/>
-                      </a:pPr>
-                      <a:r>
-                        <a:rPr/>
-                        <a:t>0.0522</a:t>
-                      </a:r>
-                    </a:p>
-                  </a:txBody>
-                </a:tc>
-                <a:tc>
-                  <a:txBody>
-                    <a:bodyPr/>
-                    <a:lstStyle/>
-                    <a:p>
-                      <a:pPr lvl="0" indent="0" marL="0">
-                        <a:buNone/>
-                      </a:pPr>
-                      <a:r>
-                        <a:rPr/>
-                        <a:t>198.4</a:t>
-                      </a:r>
-                    </a:p>
-                  </a:txBody>
-                </a:tc>
-              </a:tr>
-              <a:tr h="0">
-                <a:tc>
-                  <a:txBody>
-                    <a:bodyPr/>
-                    <a:lstStyle/>
-                    <a:p>
-                      <a:pPr lvl="0" indent="0" marL="0">
-                        <a:buNone/>
-                      </a:pPr>
-                      <a:r>
-                        <a:rPr/>
-                        <a:t>+ dropout and L2</a:t>
-                      </a:r>
-                    </a:p>
-                  </a:txBody>
-                </a:tc>
-                <a:tc>
-                  <a:txBody>
-                    <a:bodyPr/>
-                    <a:lstStyle/>
-                    <a:p>
-                      <a:pPr lvl="0" indent="0" marL="0">
-                        <a:buNone/>
-                      </a:pPr>
-                      <a:r>
-                        <a:rPr b="1"/>
-                        <a:t>0.9511</a:t>
-                      </a:r>
-                    </a:p>
-                  </a:txBody>
-                </a:tc>
-                <a:tc>
-                  <a:txBody>
-                    <a:bodyPr/>
-                    <a:lstStyle/>
-                    <a:p>
-                      <a:pPr lvl="0" indent="0" marL="0">
-                        <a:buNone/>
-                      </a:pPr>
-                      <a:r>
-                        <a:rPr/>
-                        <a:t>0.0045</a:t>
-                      </a:r>
-                    </a:p>
-                  </a:txBody>
-                </a:tc>
-                <a:tc>
-                  <a:txBody>
-                    <a:bodyPr/>
-                    <a:lstStyle/>
-                    <a:p>
-                      <a:pPr lvl="0" indent="0" marL="0">
-                        <a:buNone/>
-                      </a:pPr>
-                      <a:r>
-                        <a:rPr/>
-                        <a:t>0.0489</a:t>
-                      </a:r>
-                    </a:p>
-                  </a:txBody>
-                </a:tc>
-                <a:tc>
-                  <a:txBody>
-                    <a:bodyPr/>
-                    <a:lstStyle/>
-                    <a:p>
-                      <a:pPr lvl="0" indent="0" marL="0">
-                        <a:buNone/>
-                      </a:pPr>
-                      <a:r>
-                        <a:rPr/>
-                        <a:t>161.6</a:t>
-                      </a:r>
-                    </a:p>
-                  </a:txBody>
-                </a:tc>
-              </a:tr>
-            </a:tbl>
-          </a:graphicData>
-        </a:graphic>
-      </p:graphicFrame>
-    </p:spTree>
-  </p:cSld>
-</p:sld>
-</file>
-
-<file path=ppt/slides/slide67.xml><?xml version="1.0" encoding="utf-8"?>
 <p:sld xmlns:a="http://schemas.openxmlformats.org/drawingml/2006/main" xmlns:r="http://schemas.openxmlformats.org/officeDocument/2006/relationships" xmlns:p="http://schemas.openxmlformats.org/presentationml/2006/main">
   <p:cSld>
     <p:spTree>
@@ -20841,6 +20342,509 @@
 </p:sld>
 </file>
 
+<file path=ppt/slides/slide67.xml><?xml version="1.0" encoding="utf-8"?>
+<p:sld xmlns:a="http://schemas.openxmlformats.org/drawingml/2006/main" xmlns:r="http://schemas.openxmlformats.org/officeDocument/2006/relationships" xmlns:p="http://schemas.openxmlformats.org/presentationml/2006/main">
+  <p:cSld>
+    <p:spTree>
+      <p:nvGrpSpPr>
+        <p:cNvPr id="1" name=""/>
+        <p:cNvGrpSpPr/>
+        <p:nvPr/>
+      </p:nvGrpSpPr>
+      <p:grpSpPr>
+        <a:xfrm>
+          <a:off x="0" y="0"/>
+          <a:ext cx="0" cy="0"/>
+          <a:chOff x="0" y="0"/>
+          <a:chExt cx="0" cy="0"/>
+        </a:xfrm>
+      </p:grpSpPr>
+      <p:sp>
+        <p:nvSpPr>
+          <p:cNvPr id="2" name="Title 1"/>
+          <p:cNvSpPr>
+            <a:spLocks noGrp="1"/>
+          </p:cNvSpPr>
+          <p:nvPr>
+            <p:ph type="title"/>
+          </p:nvPr>
+        </p:nvSpPr>
+        <p:spPr>
+          <a:xfrm>
+            <a:off x="457200" y="205979"/>
+            <a:ext cx="8229600" cy="857250"/>
+          </a:xfrm>
+        </p:spPr>
+        <p:txBody>
+          <a:bodyPr/>
+          <a:lstStyle/>
+          <a:p>
+            <a:pPr lvl="0" indent="0" marL="0">
+              <a:buNone/>
+            </a:pPr>
+            <a:r>
+              <a:rPr/>
+              <a:t>Three regularisers on that network</a:t>
+            </a:r>
+          </a:p>
+        </p:txBody>
+      </p:sp>
+      <p:graphicFrame>
+        <p:nvGraphicFramePr>
+          <p:cNvPr id="6" name="Content Placeholder 5"/>
+          <p:cNvGraphicFramePr>
+            <a:graphicFrameLocks noGrp="1"/>
+          </p:cNvGraphicFramePr>
+          <p:nvPr>
+            <p:ph idx="1"/>
+          </p:nvPr>
+        </p:nvGraphicFramePr>
+        <p:xfrm>
+          <a:off x="457200" y="1166099"/>
+          <a:ext cx="8229600" cy="3390900"/>
+        </p:xfrm>
+        <a:graphic>
+          <a:graphicData uri="http://schemas.openxmlformats.org/drawingml/2006/table">
+            <a:tbl>
+              <a:tblPr firstRow="1" bandRow="1">
+                <a:tableStyleId>{5C22544A-7EE6-4342-B048-85BDC9FD1C3A}</a:tableStyleId>
+              </a:tblPr>
+              <a:tblGrid>
+                <a:gridCol w="1645920"/>
+                <a:gridCol w="1645920"/>
+                <a:gridCol w="1645920"/>
+                <a:gridCol w="1645920"/>
+                <a:gridCol w="1645920"/>
+              </a:tblGrid>
+              <a:tr h="0">
+                <a:tc>
+                  <a:txBody>
+                    <a:bodyPr/>
+                    <a:lstStyle/>
+                    <a:p>
+                      <a:pPr lvl="0" indent="0" marL="0">
+                        <a:buNone/>
+                      </a:pPr>
+                      <a:r>
+                        <a:rPr/>
+                        <a:t>method</a:t>
+                      </a:r>
+                    </a:p>
+                  </a:txBody>
+                  <a:tcPr/>
+                </a:tc>
+                <a:tc>
+                  <a:txBody>
+                    <a:bodyPr/>
+                    <a:lstStyle/>
+                    <a:p>
+                      <a:pPr lvl="0" indent="0" marL="0">
+                        <a:buNone/>
+                      </a:pPr>
+                      <a:r>
+                        <a:rPr/>
+                        <a:t>test accuracy</a:t>
+                      </a:r>
+                    </a:p>
+                  </a:txBody>
+                  <a:tcPr/>
+                </a:tc>
+                <a:tc>
+                  <a:txBody>
+                    <a:bodyPr/>
+                    <a:lstStyle/>
+                    <a:p>
+                      <a:pPr lvl="0" indent="0" marL="0">
+                        <a:buNone/>
+                      </a:pPr>
+                      <a:r>
+                        <a:rPr/>
+                        <a:t>sd over 5 seeds</a:t>
+                      </a:r>
+                    </a:p>
+                  </a:txBody>
+                  <a:tcPr/>
+                </a:tc>
+                <a:tc>
+                  <a:txBody>
+                    <a:bodyPr/>
+                    <a:lstStyle/>
+                    <a:p>
+                      <a:pPr lvl="0" indent="0" marL="0">
+                        <a:buNone/>
+                      </a:pPr>
+                      <a:r>
+                        <a:rPr/>
+                        <a:t>train − test gap</a:t>
+                      </a:r>
+                    </a:p>
+                  </a:txBody>
+                  <a:tcPr/>
+                </a:tc>
+                <a:tc>
+                  <a:txBody>
+                    <a:bodyPr/>
+                    <a:lstStyle/>
+                    <a:p>
+                      <a:pPr lvl="0" indent="0" marL="0">
+                        <a:buNone/>
+                      </a:pPr>
+                      <a:r>
+                        <a:rPr/>
+                        <a:t>epochs run</a:t>
+                      </a:r>
+                    </a:p>
+                  </a:txBody>
+                  <a:tcPr/>
+                </a:tc>
+              </a:tr>
+              <a:tr h="0">
+                <a:tc>
+                  <a:txBody>
+                    <a:bodyPr/>
+                    <a:lstStyle/>
+                    <a:p>
+                      <a:pPr lvl="0" indent="0" marL="0">
+                        <a:buNone/>
+                      </a:pPr>
+                      <a:r>
+                        <a:rPr/>
+                        <a:t>early stopping only (</a:t>
+                      </a:r>
+                      <a:r>
+                        <a:rPr>
+                          <a:latin typeface="Courier"/>
+                        </a:rPr>
+                        <a:t>EarlyStopping</a:t>
+                      </a:r>
+                      <a:r>
+                        <a:rPr/>
+                        <a:t>: keep the best epoch)</a:t>
+                      </a:r>
+                    </a:p>
+                  </a:txBody>
+                </a:tc>
+                <a:tc>
+                  <a:txBody>
+                    <a:bodyPr/>
+                    <a:lstStyle/>
+                    <a:p>
+                      <a:pPr lvl="0" indent="0" marL="0">
+                        <a:buNone/>
+                      </a:pPr>
+                      <a:r>
+                        <a:rPr/>
+                        <a:t>0.9411</a:t>
+                      </a:r>
+                    </a:p>
+                  </a:txBody>
+                </a:tc>
+                <a:tc>
+                  <a:txBody>
+                    <a:bodyPr/>
+                    <a:lstStyle/>
+                    <a:p>
+                      <a:pPr lvl="0" indent="0" marL="0">
+                        <a:buNone/>
+                      </a:pPr>
+                      <a:r>
+                        <a:rPr/>
+                        <a:t>0.0069</a:t>
+                      </a:r>
+                    </a:p>
+                  </a:txBody>
+                </a:tc>
+                <a:tc>
+                  <a:txBody>
+                    <a:bodyPr/>
+                    <a:lstStyle/>
+                    <a:p>
+                      <a:pPr lvl="0" indent="0" marL="0">
+                        <a:buNone/>
+                      </a:pPr>
+                      <a:r>
+                        <a:rPr/>
+                        <a:t>0.0589</a:t>
+                      </a:r>
+                    </a:p>
+                  </a:txBody>
+                </a:tc>
+                <a:tc>
+                  <a:txBody>
+                    <a:bodyPr/>
+                    <a:lstStyle/>
+                    <a:p>
+                      <a:pPr lvl="0" indent="0" marL="0">
+                        <a:buNone/>
+                      </a:pPr>
+                      <a:r>
+                        <a:rPr/>
+                        <a:t>38.8</a:t>
+                      </a:r>
+                    </a:p>
+                  </a:txBody>
+                </a:tc>
+              </a:tr>
+              <a:tr h="0">
+                <a:tc>
+                  <a:txBody>
+                    <a:bodyPr/>
+                    <a:lstStyle/>
+                    <a:p>
+                      <a:pPr lvl="0" indent="0" marL="0">
+                        <a:buNone/>
+                      </a:pPr>
+                      <a:r>
+                        <a:rPr/>
+                        <a:t>+ dropout 0.4 (</a:t>
+                      </a:r>
+                      <a:r>
+                        <a:rPr>
+                          <a:latin typeface="Courier"/>
+                        </a:rPr>
+                        <a:t>Dropout</a:t>
+                      </a:r>
+                      <a:r>
+                        <a:rPr/>
+                        <a:t>: drop 40% of units per batch)</a:t>
+                      </a:r>
+                    </a:p>
+                  </a:txBody>
+                </a:tc>
+                <a:tc>
+                  <a:txBody>
+                    <a:bodyPr/>
+                    <a:lstStyle/>
+                    <a:p>
+                      <a:pPr lvl="0" indent="0" marL="0">
+                        <a:buNone/>
+                      </a:pPr>
+                      <a:r>
+                        <a:rPr/>
+                        <a:t>0.9483</a:t>
+                      </a:r>
+                    </a:p>
+                  </a:txBody>
+                </a:tc>
+                <a:tc>
+                  <a:txBody>
+                    <a:bodyPr/>
+                    <a:lstStyle/>
+                    <a:p>
+                      <a:pPr lvl="0" indent="0" marL="0">
+                        <a:buNone/>
+                      </a:pPr>
+                      <a:r>
+                        <a:rPr/>
+                        <a:t>0.0038</a:t>
+                      </a:r>
+                    </a:p>
+                  </a:txBody>
+                </a:tc>
+                <a:tc>
+                  <a:txBody>
+                    <a:bodyPr/>
+                    <a:lstStyle/>
+                    <a:p>
+                      <a:pPr lvl="0" indent="0" marL="0">
+                        <a:buNone/>
+                      </a:pPr>
+                      <a:r>
+                        <a:rPr/>
+                        <a:t>0.0503</a:t>
+                      </a:r>
+                    </a:p>
+                  </a:txBody>
+                </a:tc>
+                <a:tc>
+                  <a:txBody>
+                    <a:bodyPr/>
+                    <a:lstStyle/>
+                    <a:p>
+                      <a:pPr lvl="0" indent="0" marL="0">
+                        <a:buNone/>
+                      </a:pPr>
+                      <a:r>
+                        <a:rPr/>
+                        <a:t>48.8</a:t>
+                      </a:r>
+                    </a:p>
+                  </a:txBody>
+                </a:tc>
+              </a:tr>
+              <a:tr h="0">
+                <a:tc>
+                  <a:txBody>
+                    <a:bodyPr/>
+                    <a:lstStyle/>
+                    <a:p>
+                      <a:pPr lvl="0" indent="0" marL="0">
+                        <a:buNone/>
+                      </a:pPr>
+                      <a:r>
+                        <a:rPr/>
+                        <a:t>+ L2 10⁻³ (</a:t>
+                      </a:r>
+                      <a:r>
+                        <a:rPr>
+                          <a:latin typeface="Courier"/>
+                        </a:rPr>
+                        <a:t>l2</a:t>
+                      </a:r>
+                      <a:r>
+                        <a:rPr/>
+                        <a:t>: a penalty on squared weights, as Ridge)</a:t>
+                      </a:r>
+                    </a:p>
+                  </a:txBody>
+                </a:tc>
+                <a:tc>
+                  <a:txBody>
+                    <a:bodyPr/>
+                    <a:lstStyle/>
+                    <a:p>
+                      <a:pPr lvl="0" indent="0" marL="0">
+                        <a:buNone/>
+                      </a:pPr>
+                      <a:r>
+                        <a:rPr/>
+                        <a:t>0.9478</a:t>
+                      </a:r>
+                    </a:p>
+                  </a:txBody>
+                </a:tc>
+                <a:tc>
+                  <a:txBody>
+                    <a:bodyPr/>
+                    <a:lstStyle/>
+                    <a:p>
+                      <a:pPr lvl="0" indent="0" marL="0">
+                        <a:buNone/>
+                      </a:pPr>
+                      <a:r>
+                        <a:rPr/>
+                        <a:t>0.0011</a:t>
+                      </a:r>
+                    </a:p>
+                  </a:txBody>
+                </a:tc>
+                <a:tc>
+                  <a:txBody>
+                    <a:bodyPr/>
+                    <a:lstStyle/>
+                    <a:p>
+                      <a:pPr lvl="0" indent="0" marL="0">
+                        <a:buNone/>
+                      </a:pPr>
+                      <a:r>
+                        <a:rPr/>
+                        <a:t>0.0522</a:t>
+                      </a:r>
+                    </a:p>
+                  </a:txBody>
+                </a:tc>
+                <a:tc>
+                  <a:txBody>
+                    <a:bodyPr/>
+                    <a:lstStyle/>
+                    <a:p>
+                      <a:pPr lvl="0" indent="0" marL="0">
+                        <a:buNone/>
+                      </a:pPr>
+                      <a:r>
+                        <a:rPr/>
+                        <a:t>198.4</a:t>
+                      </a:r>
+                    </a:p>
+                  </a:txBody>
+                </a:tc>
+              </a:tr>
+              <a:tr h="0">
+                <a:tc>
+                  <a:txBody>
+                    <a:bodyPr/>
+                    <a:lstStyle/>
+                    <a:p>
+                      <a:pPr lvl="0" indent="0" marL="0">
+                        <a:buNone/>
+                      </a:pPr>
+                      <a:r>
+                        <a:rPr/>
+                        <a:t>+ dropout and L2</a:t>
+                      </a:r>
+                    </a:p>
+                  </a:txBody>
+                </a:tc>
+                <a:tc>
+                  <a:txBody>
+                    <a:bodyPr/>
+                    <a:lstStyle/>
+                    <a:p>
+                      <a:pPr lvl="0" indent="0" marL="0">
+                        <a:buNone/>
+                      </a:pPr>
+                      <a:r>
+                        <a:rPr b="1"/>
+                        <a:t>0.9511</a:t>
+                      </a:r>
+                    </a:p>
+                  </a:txBody>
+                </a:tc>
+                <a:tc>
+                  <a:txBody>
+                    <a:bodyPr/>
+                    <a:lstStyle/>
+                    <a:p>
+                      <a:pPr lvl="0" indent="0" marL="0">
+                        <a:buNone/>
+                      </a:pPr>
+                      <a:r>
+                        <a:rPr/>
+                        <a:t>0.0045</a:t>
+                      </a:r>
+                    </a:p>
+                  </a:txBody>
+                </a:tc>
+                <a:tc>
+                  <a:txBody>
+                    <a:bodyPr/>
+                    <a:lstStyle/>
+                    <a:p>
+                      <a:pPr lvl="0" indent="0" marL="0">
+                        <a:buNone/>
+                      </a:pPr>
+                      <a:r>
+                        <a:rPr/>
+                        <a:t>0.0489</a:t>
+                      </a:r>
+                    </a:p>
+                  </a:txBody>
+                </a:tc>
+                <a:tc>
+                  <a:txBody>
+                    <a:bodyPr/>
+                    <a:lstStyle/>
+                    <a:p>
+                      <a:pPr lvl="0" indent="0" marL="0">
+                        <a:buNone/>
+                      </a:pPr>
+                      <a:r>
+                        <a:rPr/>
+                        <a:t>161.6</a:t>
+                      </a:r>
+                    </a:p>
+                  </a:txBody>
+                </a:tc>
+              </a:tr>
+            </a:tbl>
+          </a:graphicData>
+        </a:graphic>
+      </p:graphicFrame>
+    </p:spTree>
+  </p:cSld>
+</p:sld>
+</file>
+
 <file path=ppt/slides/slide68.xml><?xml version="1.0" encoding="utf-8"?>
 <p:sld xmlns:a="http://schemas.openxmlformats.org/drawingml/2006/main" xmlns:r="http://schemas.openxmlformats.org/officeDocument/2006/relationships" xmlns:p="http://schemas.openxmlformats.org/presentationml/2006/main">
   <p:cSld>
@@ -21091,7 +21095,7 @@
                       </a:pPr>
                       <a:r>
                         <a:rPr/>
-                        <a:t>memorising, 67</a:t>
+                        <a:t>memorising, 66</a:t>
                       </a:r>
                     </a:p>
                   </a:txBody>
@@ -21133,7 +21137,7 @@
                       </a:pPr>
                       <a:r>
                         <a:rPr/>
-                        <a:t>regularisers, 66</a:t>
+                        <a:t>regularisers, 67</a:t>
                       </a:r>
                     </a:p>
                   </a:txBody>

</xml_diff>

<commit_message>
Show the general circle formula on lesson 9's slide 12
Slide 12 now gives P(|z| < s) = 1 - exp(-s^2/2) beside its value at
s = 1.25, 0.5422; the notes keep the 0.78125 step and point to the
derivation in handout section 2.2.

Co-Authored-By: Claude Opus 5.5 <noreply@anthropic.com>
</commit_message>
<xml_diff>
--- a/Lessons/09_neural_networks/Slides/neural_networks_slides.pptx
+++ b/Lessons/09_neural_networks/Slides/neural_networks_slides.pptx
@@ -841,7 +841,7 @@
             </a:pPr>
             <a:r>
               <a:rPr/>
-              <a:t>Read the symbols: z is one unit’s pair of standardised offsets, the double bars are its distance from the origin, so the left side is “the probability that a unit lands inside the circle of radius 1.25” - the probability that it passes. For a standard two-dimensional normal the probability of landing inside a circle of radius s is one minus e to the minus s squared over two. The middle step is left off the slide so the formula stays large enough to read: 1.25 squared over two is 0.78125, and that is the exponent. Do it out loud.</a:t>
+              <a:t>Read the symbols: z is one unit’s pair of standardised offsets, the double bars are its distance from the origin. The first formula is the general fact: for a standard two-dimensional normal, the probability of landing inside a circle of radius s is one minus e to the minus s squared over two (handout section 2.2 derives it in three lines, in polar coordinates). The second puts in s = 1.25, the radius of the accept region, so its left side is “the probability that a unit lands inside the circle” - the probability that it passes. 1.25 squared over two is 0.78125, and that is the exponent. Do it out loud.</a:t>
             </a:r>
           </a:p>
           <a:p>
@@ -12026,7 +12026,7 @@
       </p:sp>
       <p:pic>
         <p:nvPicPr>
-          <p:cNvPr descr="eq_e163dd354e.png" id="0" name="Picture 1"/>
+          <p:cNvPr descr="eq_3638bdf1b5.png" id="0" name="Picture 1"/>
           <p:cNvPicPr>
             <a:picLocks noGrp="1" noChangeAspect="1"/>
           </p:cNvPicPr>
@@ -12040,8 +12040,8 @@
         </p:blipFill>
         <p:spPr bwMode="auto">
           <a:xfrm>
-            <a:off x="457200" y="2547739"/>
-            <a:ext cx="8229600" cy="596900"/>
+            <a:off x="457200" y="2573139"/>
+            <a:ext cx="8229600" cy="546100"/>
           </a:xfrm>
           <a:prstGeom prst="rect">
             <a:avLst/>

</xml_diff>

<commit_message>
Stop calling lesson 9's 0.6491 exact
Slide 16 said the honest best-line figure was computed exactly from the
geometry, and its notes said analytically rather than from any sample.
For one line notebook 1 slides a boundary across 400,000 units simulated
from the true rule, so it carries about 0.001, and the handout's
quadrature gives 0.6500. The slide now says it comes from the true
distribution, not the test set, with its uncertainty; the notes say how
it is computed, and the quiz answer no longer claims an integral.

Co-Authored-By: Claude Opus 5.5 <noreply@anthropic.com>
</commit_message>
<xml_diff>
--- a/Lessons/09_neural_networks/Slides/neural_networks_slides.pptx
+++ b/Lessons/09_neural_networks/Slides/neural_networks_slides.pptx
@@ -1351,7 +1351,7 @@
             </a:pPr>
             <a:r>
               <a:rPr/>
-              <a:t>The 0.6491 is computed analytically in handout section 11.1, from the geometry rather than from any sample, which is precisely why it is trustworthy here. Handout section 2.2.</a:t>
+              <a:t>The 0.6491 does not use the test set at all. It is the best a straight line can do on the whole population: by the circle’s symmetry every direction is equivalent, so notebook 1 slides one line x1 &lt; a across 400,000 units simulated from the true rule, keeps the best position, and converts to accuracy against the recorded labels with the 3% rig error. Being a simulation it carries about plus or minus 0.001 - the handout’s quadrature gives 0.6500 - which changes nothing: 0.6880 against about 0.65 is still almost 4 points. Handout sections 2.2 and 11.1. Handout section 2.2.</a:t>
             </a:r>
           </a:p>
         </p:txBody>
@@ -12579,11 +12579,15 @@
             <a:pPr lvl="0"/>
             <a:r>
               <a:rPr/>
-              <a:t>The honest figure, computed exactly from the geometry: </a:t>
+              <a:t>The honest figure, from the true distribution, not from any test set: </a:t>
             </a:r>
             <a:r>
               <a:rPr b="1"/>
               <a:t>0.6491</a:t>
+            </a:r>
+            <a:r>
+              <a:rPr/>
+              <a:t> (±0.001)</a:t>
             </a:r>
           </a:p>
           <a:p>

</xml_diff>

<commit_message>
Define mini-batch and epoch in lesson 9 where they first appear
Slide 33 said mini-batching and slide 42 batch size, but mini-batches
were defined only on slide 65, and epoch nowhere on a slide, though
notebook 1 already trains on batches of 64 and five slides quote epochs.
Slide 33 now defines a mini-batch step, slide 42 says what batch size
counts, and slide 54 defines an epoch; handout section 4.1 and notebook
1's training section carry the same definitions.

Co-Authored-By: Claude Opus 5.5 <noreply@anthropic.com>
</commit_message>
<xml_diff>
--- a/Lessons/09_neural_networks/Slides/neural_networks_slides.pptx
+++ b/Lessons/09_neural_networks/Slides/neural_networks_slides.pptx
@@ -3432,7 +3432,7 @@
             </a:pPr>
             <a:r>
               <a:rPr/>
-              <a:t>Both facts look like bookkeeping, but both matter. The first is what allows every later decision to process examples in batches, or to split them across machines; if examples could influence one another, computing a gradient on 32 of them would not approximate the gradient on all of them.</a:t>
+              <a:t>Both facts look like bookkeeping, but both matter. The first: nothing in the forward pass lets example 3 influence example 7. That is what allows training to process examples in batches, or to split them across machines. Define the term here, because it is new: lesson 3’s gradient descent computed every step’s gradient on all m examples; a mini-batch step computes it on a small random group - 64 in notebook 1 - takes the step, then moves to the next group. The number in each group is the batch size. It works only because examples do not mix: if they could influence one another, the gradient on 64 of them would not approximate the gradient on all of them. The full story, and how batch size interacts with the learning rate, comes back with the optimisers in the last segment (handout section 9.2).</a:t>
             </a:r>
           </a:p>
           <a:p>
@@ -15214,21 +15214,26 @@
             <a:pPr lvl="0"/>
             <a:r>
               <a:rPr/>
-              <a:t>Nothing lets example 3 influence example 7, which is what makes mini-batching valid</a:t>
+              <a:t>So a step can use a </a:t>
+            </a:r>
+            <a:r>
+              <a:rPr b="1"/>
+              <a:t>mini-batch</a:t>
+            </a:r>
+            <a:r>
+              <a:rPr/>
+              <a:t>: the gradient on a few examples (64 in notebook 1), not all m</a:t>
             </a:r>
           </a:p>
           <a:p>
             <a:pPr lvl="0"/>
             <a:r>
               <a:rPr b="1"/>
-              <a:t>Each column of the first weight matrix is one unit</a:t>
-            </a:r>
-          </a:p>
-          <a:p>
-            <a:pPr lvl="0"/>
-            <a:r>
-              <a:rPr/>
-              <a:t>Its weight vector, and the line that unit draws</a:t>
+              <a:t>Each column of W⁽¹⁾ is one unit</a:t>
+            </a:r>
+            <a:r>
+              <a:rPr/>
+              <a:t>: its weights, and the line it draws</a:t>
             </a:r>
           </a:p>
           <a:p>
@@ -16245,7 +16250,7 @@
             <a:pPr lvl="0"/>
             <a:r>
               <a:rPr/>
-              <a:t>Memory grows with depth times batch size, and memory, not arithmetic, is what usually limits batch size</a:t>
+              <a:t>Memory grows with depth times batch size (examples per mini-batch), and memory, not arithmetic, is what usually limits batch size</a:t>
             </a:r>
           </a:p>
         </p:txBody>
@@ -18069,7 +18074,7 @@
             </a:pPr>
             <a:r>
               <a:rPr/>
-              <a:t>Eighty epochs, three activations: only the sigmoid never learns</a:t>
+              <a:t>Eighty epochs: only the sigmoid never learns</a:t>
             </a:r>
           </a:p>
         </p:txBody>
@@ -18097,7 +18102,7 @@
             <a:pPr lvl="0"/>
             <a:r>
               <a:rPr/>
-              <a:t>Same six layers, same data, differing </a:t>
+              <a:t>Same six layers and data, </a:t>
             </a:r>
             <a:r>
               <a:rPr b="1"/>
@@ -18105,7 +18110,15 @@
             </a:r>
             <a:r>
               <a:rPr/>
-              <a:t> in the activation</a:t>
+              <a:t> the activation differs; an </a:t>
+            </a:r>
+            <a:r>
+              <a:rPr b="1"/>
+              <a:t>epoch</a:t>
+            </a:r>
+            <a:r>
+              <a:rPr/>
+              <a:t> is one pass through the training set</a:t>
             </a:r>
           </a:p>
           <a:p>
@@ -18142,7 +18155,7 @@
             <a:pPr lvl="0"/>
             <a:r>
               <a:rPr/>
-              <a:t>Rectified linear unit: </a:t>
+              <a:t>ReLU: </a:t>
             </a:r>
             <a:r>
               <a:rPr b="1"/>

</xml_diff>